<commit_message>
docs(deck): refresh overview deck for v0.1.3
Bring the customer-facing overview deck in line with what's shipped:

- Slides 1, 12: version footer v0.1.1 -> v0.1.3

- Slides 4, 5, 6, 12: CLI examples lead with --all-subs (matches the README quick start added in v0.1.2)

- Slide 11: 'Unit tests + CI' rephrased to 'CI on PRs (pytest + py_compile)' since fixture tests for rightsizing-peak and context-enricher shipped in v0.1.3

- Slide 11: version-train footer now has a 'Shipped' line (v0.1.2 --all-subs, v0.1.3 fixture tests) above the 'Next' line

- Slide 12: 'WHAT YOU NEED' bullet mentions --all-subs as an option

Adds docs/_update_deck.py - an idempotent python-pptx script that performs the edits at the run level, preserving the deck's hand-tuned formatting (no regeneration).

Co-authored-by: Copilot <223556219+Copilot@users.noreply.github.com>
</commit_message>
<xml_diff>
--- a/docs/finops-engine-overview.pptx
+++ b/docs/finops-engine-overview.pptx
@@ -3557,7 +3557,7 @@
                 </a:solidFill>
                 <a:latin typeface="Calibri"/>
               </a:rPr>
-              <a:t>v0.1.1</a:t>
+              <a:t>v0.1.3</a:t>
             </a:r>
           </a:p>
         </p:txBody>
@@ -6358,7 +6358,7 @@
                 </a:solidFill>
                 <a:latin typeface="Calibri"/>
               </a:rPr>
-              <a:t>•  Unit tests + CI</a:t>
+              <a:t>•  CI on PRs (pytest + py_compile)</a:t>
             </a:r>
           </a:p>
           <a:p>
@@ -6685,7 +6685,8 @@
                 </a:solidFill>
                 <a:latin typeface="Calibri"/>
               </a:rPr>
-              <a:t>v0.2.0  →  low-risk wins   ·   v0.3.0  →  trust-the-automation bundle   ·   v1.0.0  →  schema lock + tests + CI</a:t>
+              <a:t>Shipped:  v0.1.2  --all-subs  ·  v0.1.3  fixture tests
+Next:  v0.2.0  →  low-risk wins   ·   v0.3.0  →  trust-the-automation bundle   ·   v1.0.0  →  schema lock + CI</a:t>
             </a:r>
           </a:p>
         </p:txBody>
@@ -7011,14 +7012,13 @@
               <a:t>git clone https://github.com/prbeegala/FinOpsEngine.git
 cd FinOpsEngine
 az login
-az account set --subscription &lt;default-sub-id&gt;
 python tools/rightsizing-peak/rightsizing_peak.py `
-    --subs &lt;sub1&gt;,&lt;sub2&gt; `
+    --all-subs `
     --days 30 `
-    --out-dir ./out/peak-rightsizing
+    --out-dir ./out/peak
 python tools/hidden-waste/hidden_waste.py `
-    --subs &lt;sub1&gt;,&lt;sub2&gt; `
-    --out-dir ./out/hidden-waste
+    --all-subs `
+    --out-dir ./out/hidden
 </a:t>
             </a:r>
           </a:p>
@@ -7170,7 +7170,7 @@
                 </a:solidFill>
                 <a:latin typeface="Calibri"/>
               </a:rPr>
-              <a:t>•  A list of subscription IDs.</a:t>
+              <a:t>•  A list of subscription IDs, or --all-subs for tenant-wide.</a:t>
             </a:r>
           </a:p>
         </p:txBody>
@@ -7311,7 +7311,7 @@
                 </a:solidFill>
                 <a:latin typeface="Calibri"/>
               </a:rPr>
-              <a:t>github.com/prbeegala/FinOpsEngine    ·    Open source · MIT · v0.1.1</a:t>
+              <a:t>github.com/prbeegala/FinOpsEngine    ·    Open source · MIT · v0.1.3</a:t>
             </a:r>
           </a:p>
         </p:txBody>
@@ -9832,7 +9832,7 @@
               </a:rPr>
               <a:t>python tools/rightsizing-peak/
   rightsizing_peak.py `
-  --subs &lt;sub1&gt;,&lt;sub2&gt; `
+  --all-subs `
   --days 30 `
   --out-dir ./out/peak `
   --downsize-cpu-p95-max 80 `
@@ -10450,7 +10450,7 @@
               </a:rPr>
               <a:t>python tools/hidden-waste/
   hidden_waste.py `
-  --subs &lt;sub1&gt;,&lt;sub2&gt; `
+  --all-subs `
   --out-dir ./out/hidden
 # Outputs:
 #  hidden-waste-&lt;date&gt;.md
@@ -11069,7 +11069,7 @@
               </a:rPr>
               <a:t>python tools/ri-coverage/
   ri_coverage.py `
-  --subs &lt;sub1&gt;,&lt;sub2&gt; `
+  --all-subs `
   --out-dir ./out/ri
 # Outputs:
 #  ri-coverage-&lt;date&gt;.md

</xml_diff>

<commit_message>
docs(deck): refresh overview deck for v0.1.3 (#43)
Bring the customer-facing overview deck in line with what's shipped:

- Slides 1, 12: version footer v0.1.1 -> v0.1.3

- Slides 4, 5, 6, 12: CLI examples lead with --all-subs (matches the README quick start added in v0.1.2)

- Slide 11: 'Unit tests + CI' rephrased to 'CI on PRs (pytest + py_compile)' since fixture tests for rightsizing-peak and context-enricher shipped in v0.1.3

- Slide 11: version-train footer now has a 'Shipped' line (v0.1.2 --all-subs, v0.1.3 fixture tests) above the 'Next' line

- Slide 12: 'WHAT YOU NEED' bullet mentions --all-subs as an option

Adds docs/_update_deck.py - an idempotent python-pptx script that performs the edits at the run level, preserving the deck's hand-tuned formatting (no regeneration).

Co-authored-by: Copilot <223556219+Copilot@users.noreply.github.com>
</commit_message>
<xml_diff>
--- a/docs/finops-engine-overview.pptx
+++ b/docs/finops-engine-overview.pptx
@@ -3557,7 +3557,7 @@
                 </a:solidFill>
                 <a:latin typeface="Calibri"/>
               </a:rPr>
-              <a:t>v0.1.1</a:t>
+              <a:t>v0.1.3</a:t>
             </a:r>
           </a:p>
         </p:txBody>
@@ -6358,7 +6358,7 @@
                 </a:solidFill>
                 <a:latin typeface="Calibri"/>
               </a:rPr>
-              <a:t>•  Unit tests + CI</a:t>
+              <a:t>•  CI on PRs (pytest + py_compile)</a:t>
             </a:r>
           </a:p>
           <a:p>
@@ -6685,7 +6685,8 @@
                 </a:solidFill>
                 <a:latin typeface="Calibri"/>
               </a:rPr>
-              <a:t>v0.2.0  →  low-risk wins   ·   v0.3.0  →  trust-the-automation bundle   ·   v1.0.0  →  schema lock + tests + CI</a:t>
+              <a:t>Shipped:  v0.1.2  --all-subs  ·  v0.1.3  fixture tests
+Next:  v0.2.0  →  low-risk wins   ·   v0.3.0  →  trust-the-automation bundle   ·   v1.0.0  →  schema lock + CI</a:t>
             </a:r>
           </a:p>
         </p:txBody>
@@ -7011,14 +7012,13 @@
               <a:t>git clone https://github.com/prbeegala/FinOpsEngine.git
 cd FinOpsEngine
 az login
-az account set --subscription &lt;default-sub-id&gt;
 python tools/rightsizing-peak/rightsizing_peak.py `
-    --subs &lt;sub1&gt;,&lt;sub2&gt; `
+    --all-subs `
     --days 30 `
-    --out-dir ./out/peak-rightsizing
+    --out-dir ./out/peak
 python tools/hidden-waste/hidden_waste.py `
-    --subs &lt;sub1&gt;,&lt;sub2&gt; `
-    --out-dir ./out/hidden-waste
+    --all-subs `
+    --out-dir ./out/hidden
 </a:t>
             </a:r>
           </a:p>
@@ -7170,7 +7170,7 @@
                 </a:solidFill>
                 <a:latin typeface="Calibri"/>
               </a:rPr>
-              <a:t>•  A list of subscription IDs.</a:t>
+              <a:t>•  A list of subscription IDs, or --all-subs for tenant-wide.</a:t>
             </a:r>
           </a:p>
         </p:txBody>
@@ -7311,7 +7311,7 @@
                 </a:solidFill>
                 <a:latin typeface="Calibri"/>
               </a:rPr>
-              <a:t>github.com/prbeegala/FinOpsEngine    ·    Open source · MIT · v0.1.1</a:t>
+              <a:t>github.com/prbeegala/FinOpsEngine    ·    Open source · MIT · v0.1.3</a:t>
             </a:r>
           </a:p>
         </p:txBody>
@@ -9832,7 +9832,7 @@
               </a:rPr>
               <a:t>python tools/rightsizing-peak/
   rightsizing_peak.py `
-  --subs &lt;sub1&gt;,&lt;sub2&gt; `
+  --all-subs `
   --days 30 `
   --out-dir ./out/peak `
   --downsize-cpu-p95-max 80 `
@@ -10450,7 +10450,7 @@
               </a:rPr>
               <a:t>python tools/hidden-waste/
   hidden_waste.py `
-  --subs &lt;sub1&gt;,&lt;sub2&gt; `
+  --all-subs `
   --out-dir ./out/hidden
 # Outputs:
 #  hidden-waste-&lt;date&gt;.md
@@ -11069,7 +11069,7 @@
               </a:rPr>
               <a:t>python tools/ri-coverage/
   ri_coverage.py `
-  --subs &lt;sub1&gt;,&lt;sub2&gt; `
+  --all-subs `
   --out-dir ./out/ri
 # Outputs:
 #  ri-coverage-&lt;date&gt;.md

</xml_diff>